<commit_message>
Corregir composición de presentación de Amaal
</commit_message>
<xml_diff>
--- a/amaal/presentacion/Defensa_Amaal_10_laminas.pptx
+++ b/amaal/presentacion/Defensa_Amaal_10_laminas.pptx
@@ -2651,7 +2651,7 @@
         </p:nvSpPr>
         <p:spPr>
           <a:xfrm>
-            <a:off x="658368" y="868680"/>
+            <a:off x="658368" y="1508760"/>
             <a:ext cx="10789920" cy="658368"/>
           </a:xfrm>
           <a:prstGeom prst="rect">
@@ -2690,7 +2690,7 @@
         </p:nvSpPr>
         <p:spPr>
           <a:xfrm>
-            <a:off x="640080" y="2514600"/>
+            <a:off x="640080" y="2971800"/>
             <a:ext cx="2157984" cy="2286000"/>
           </a:xfrm>
           <a:prstGeom prst="rect">
@@ -2715,7 +2715,7 @@
         </p:nvSpPr>
         <p:spPr>
           <a:xfrm>
-            <a:off x="640080" y="2514600"/>
+            <a:off x="640080" y="2971800"/>
             <a:ext cx="2157984" cy="73152"/>
           </a:xfrm>
           <a:prstGeom prst="rect">
@@ -2740,7 +2740,7 @@
         </p:nvSpPr>
         <p:spPr>
           <a:xfrm>
-            <a:off x="786384" y="2852928"/>
+            <a:off x="786384" y="3310128"/>
             <a:ext cx="1865376" cy="274320"/>
           </a:xfrm>
           <a:prstGeom prst="rect">
@@ -2776,7 +2776,7 @@
         </p:nvSpPr>
         <p:spPr>
           <a:xfrm>
-            <a:off x="804672" y="3291840"/>
+            <a:off x="804672" y="3749040"/>
             <a:ext cx="1828800" cy="914400"/>
           </a:xfrm>
           <a:prstGeom prst="rect">
@@ -2812,7 +2812,7 @@
         </p:nvSpPr>
         <p:spPr>
           <a:xfrm>
-            <a:off x="2935224" y="2514600"/>
+            <a:off x="2935224" y="2971800"/>
             <a:ext cx="2157984" cy="2286000"/>
           </a:xfrm>
           <a:prstGeom prst="rect">
@@ -2837,7 +2837,7 @@
         </p:nvSpPr>
         <p:spPr>
           <a:xfrm>
-            <a:off x="2935224" y="2514600"/>
+            <a:off x="2935224" y="2971800"/>
             <a:ext cx="2157984" cy="73152"/>
           </a:xfrm>
           <a:prstGeom prst="rect">
@@ -2862,7 +2862,7 @@
         </p:nvSpPr>
         <p:spPr>
           <a:xfrm>
-            <a:off x="3081528" y="2852928"/>
+            <a:off x="3081528" y="3310128"/>
             <a:ext cx="1865376" cy="274320"/>
           </a:xfrm>
           <a:prstGeom prst="rect">
@@ -2898,7 +2898,7 @@
         </p:nvSpPr>
         <p:spPr>
           <a:xfrm>
-            <a:off x="3099816" y="3291840"/>
+            <a:off x="3099816" y="3749040"/>
             <a:ext cx="1828800" cy="914400"/>
           </a:xfrm>
           <a:prstGeom prst="rect">
@@ -2934,7 +2934,7 @@
         </p:nvSpPr>
         <p:spPr>
           <a:xfrm>
-            <a:off x="5230368" y="2514600"/>
+            <a:off x="5230368" y="2971800"/>
             <a:ext cx="2157984" cy="2286000"/>
           </a:xfrm>
           <a:prstGeom prst="rect">
@@ -2959,7 +2959,7 @@
         </p:nvSpPr>
         <p:spPr>
           <a:xfrm>
-            <a:off x="5230368" y="2514600"/>
+            <a:off x="5230368" y="2971800"/>
             <a:ext cx="2157984" cy="73152"/>
           </a:xfrm>
           <a:prstGeom prst="rect">
@@ -2984,7 +2984,7 @@
         </p:nvSpPr>
         <p:spPr>
           <a:xfrm>
-            <a:off x="5376672" y="2852928"/>
+            <a:off x="5376672" y="3310128"/>
             <a:ext cx="1865376" cy="274320"/>
           </a:xfrm>
           <a:prstGeom prst="rect">
@@ -3020,7 +3020,7 @@
         </p:nvSpPr>
         <p:spPr>
           <a:xfrm>
-            <a:off x="5394960" y="3291840"/>
+            <a:off x="5394960" y="3749040"/>
             <a:ext cx="1828800" cy="914400"/>
           </a:xfrm>
           <a:prstGeom prst="rect">
@@ -3056,7 +3056,7 @@
         </p:nvSpPr>
         <p:spPr>
           <a:xfrm>
-            <a:off x="7525512" y="2514600"/>
+            <a:off x="7525512" y="2971800"/>
             <a:ext cx="2157984" cy="2286000"/>
           </a:xfrm>
           <a:prstGeom prst="rect">
@@ -3081,7 +3081,7 @@
         </p:nvSpPr>
         <p:spPr>
           <a:xfrm>
-            <a:off x="7525512" y="2514600"/>
+            <a:off x="7525512" y="2971800"/>
             <a:ext cx="2157984" cy="73152"/>
           </a:xfrm>
           <a:prstGeom prst="rect">
@@ -3106,7 +3106,7 @@
         </p:nvSpPr>
         <p:spPr>
           <a:xfrm>
-            <a:off x="7671816" y="2852928"/>
+            <a:off x="7671816" y="3310128"/>
             <a:ext cx="1865376" cy="274320"/>
           </a:xfrm>
           <a:prstGeom prst="rect">
@@ -3142,7 +3142,7 @@
         </p:nvSpPr>
         <p:spPr>
           <a:xfrm>
-            <a:off x="7690104" y="3291840"/>
+            <a:off x="7690104" y="3749040"/>
             <a:ext cx="1828800" cy="914400"/>
           </a:xfrm>
           <a:prstGeom prst="rect">
@@ -3178,7 +3178,7 @@
         </p:nvSpPr>
         <p:spPr>
           <a:xfrm>
-            <a:off x="9820656" y="2514600"/>
+            <a:off x="9820656" y="2971800"/>
             <a:ext cx="2157984" cy="2286000"/>
           </a:xfrm>
           <a:prstGeom prst="rect">
@@ -3203,7 +3203,7 @@
         </p:nvSpPr>
         <p:spPr>
           <a:xfrm>
-            <a:off x="9820656" y="2514600"/>
+            <a:off x="9820656" y="2971800"/>
             <a:ext cx="2157984" cy="73152"/>
           </a:xfrm>
           <a:prstGeom prst="rect">
@@ -3228,7 +3228,7 @@
         </p:nvSpPr>
         <p:spPr>
           <a:xfrm>
-            <a:off x="9966960" y="2852928"/>
+            <a:off x="9966960" y="3310128"/>
             <a:ext cx="1865376" cy="274320"/>
           </a:xfrm>
           <a:prstGeom prst="rect">
@@ -3264,7 +3264,7 @@
         </p:nvSpPr>
         <p:spPr>
           <a:xfrm>
-            <a:off x="9985248" y="3291840"/>
+            <a:off x="9985248" y="3749040"/>
             <a:ext cx="1828800" cy="914400"/>
           </a:xfrm>
           <a:prstGeom prst="rect">
@@ -3550,8 +3550,8 @@
         </p:nvSpPr>
         <p:spPr>
           <a:xfrm>
-            <a:off x="4572000" y="2066544"/>
-            <a:ext cx="6537960" cy="292608"/>
+            <a:off x="4572000" y="2011680"/>
+            <a:ext cx="6537960" cy="475488"/>
           </a:xfrm>
           <a:prstGeom prst="rect">
             <a:avLst/>
@@ -3579,28 +3579,6 @@
             </a:r>
             <a:endParaRPr lang="en-US" sz="900" dirty="0"/>
           </a:p>
-        </p:txBody>
-      </p:sp>
-      <p:sp>
-        <p:nvSpPr>
-          <p:cNvPr id="9" name="Text 6"/>
-          <p:cNvSpPr/>
-          <p:nvPr/>
-        </p:nvSpPr>
-        <p:spPr>
-          <a:xfrm>
-            <a:off x="4572000" y="2423160"/>
-            <a:ext cx="6537960" cy="36576"/>
-          </a:xfrm>
-          <a:prstGeom prst="rect">
-            <a:avLst/>
-          </a:prstGeom>
-          <a:noFill/>
-          <a:ln/>
-        </p:spPr>
-        <p:txBody>
-          <a:bodyPr wrap="square" lIns="0" tIns="0" rIns="0" bIns="0" rtlCol="0" anchor="ctr"/>
-          <a:lstStyle/>
           <a:p>
             <a:pPr indent="0" marL="0">
               <a:buNone/>
@@ -3616,13 +3594,13 @@
               </a:rPr>
               <a:t>Ingeniería de Telecomunicaciones, C.A.</a:t>
             </a:r>
-            <a:endParaRPr lang="en-US" sz="1400" dirty="0"/>
-          </a:p>
-        </p:txBody>
-      </p:sp>
-      <p:sp>
-        <p:nvSpPr>
-          <p:cNvPr id="10" name="Shape 7"/>
+            <a:endParaRPr lang="en-US" sz="900" dirty="0"/>
+          </a:p>
+        </p:txBody>
+      </p:sp>
+      <p:sp>
+        <p:nvSpPr>
+          <p:cNvPr id="9" name="Shape 6"/>
           <p:cNvSpPr/>
           <p:nvPr/>
         </p:nvSpPr>
@@ -3647,7 +3625,7 @@
       </p:sp>
       <p:sp>
         <p:nvSpPr>
-          <p:cNvPr id="11" name="Shape 8"/>
+          <p:cNvPr id="10" name="Shape 7"/>
           <p:cNvSpPr/>
           <p:nvPr/>
         </p:nvSpPr>
@@ -3672,14 +3650,14 @@
       </p:sp>
       <p:sp>
         <p:nvSpPr>
-          <p:cNvPr id="12" name="Text 9"/>
-          <p:cNvSpPr/>
-          <p:nvPr/>
-        </p:nvSpPr>
-        <p:spPr>
-          <a:xfrm>
-            <a:off x="4572000" y="2871216"/>
-            <a:ext cx="6537960" cy="292608"/>
+          <p:cNvPr id="11" name="Text 8"/>
+          <p:cNvSpPr/>
+          <p:nvPr/>
+        </p:nvSpPr>
+        <p:spPr>
+          <a:xfrm>
+            <a:off x="4572000" y="2816352"/>
+            <a:ext cx="6537960" cy="475488"/>
           </a:xfrm>
           <a:prstGeom prst="rect">
             <a:avLst/>
@@ -3707,28 +3685,6 @@
             </a:r>
             <a:endParaRPr lang="en-US" sz="900" dirty="0"/>
           </a:p>
-        </p:txBody>
-      </p:sp>
-      <p:sp>
-        <p:nvSpPr>
-          <p:cNvPr id="13" name="Text 10"/>
-          <p:cNvSpPr/>
-          <p:nvPr/>
-        </p:nvSpPr>
-        <p:spPr>
-          <a:xfrm>
-            <a:off x="4572000" y="3227832"/>
-            <a:ext cx="6537960" cy="36576"/>
-          </a:xfrm>
-          <a:prstGeom prst="rect">
-            <a:avLst/>
-          </a:prstGeom>
-          <a:noFill/>
-          <a:ln/>
-        </p:spPr>
-        <p:txBody>
-          <a:bodyPr wrap="square" lIns="0" tIns="0" rIns="0" bIns="0" rtlCol="0" anchor="ctr"/>
-          <a:lstStyle/>
           <a:p>
             <a:pPr indent="0" marL="0">
               <a:buNone/>
@@ -3744,13 +3700,13 @@
               </a:rPr>
               <a:t>Telecomunicaciones y automatización</a:t>
             </a:r>
-            <a:endParaRPr lang="en-US" sz="1400" dirty="0"/>
-          </a:p>
-        </p:txBody>
-      </p:sp>
-      <p:sp>
-        <p:nvSpPr>
-          <p:cNvPr id="14" name="Shape 11"/>
+            <a:endParaRPr lang="en-US" sz="900" dirty="0"/>
+          </a:p>
+        </p:txBody>
+      </p:sp>
+      <p:sp>
+        <p:nvSpPr>
+          <p:cNvPr id="12" name="Shape 9"/>
           <p:cNvSpPr/>
           <p:nvPr/>
         </p:nvSpPr>
@@ -3775,7 +3731,7 @@
       </p:sp>
       <p:sp>
         <p:nvSpPr>
-          <p:cNvPr id="15" name="Shape 12"/>
+          <p:cNvPr id="13" name="Shape 10"/>
           <p:cNvSpPr/>
           <p:nvPr/>
         </p:nvSpPr>
@@ -3800,14 +3756,14 @@
       </p:sp>
       <p:sp>
         <p:nvSpPr>
-          <p:cNvPr id="16" name="Text 13"/>
-          <p:cNvSpPr/>
-          <p:nvPr/>
-        </p:nvSpPr>
-        <p:spPr>
-          <a:xfrm>
-            <a:off x="4572000" y="3675888"/>
-            <a:ext cx="6537960" cy="292608"/>
+          <p:cNvPr id="14" name="Text 11"/>
+          <p:cNvSpPr/>
+          <p:nvPr/>
+        </p:nvSpPr>
+        <p:spPr>
+          <a:xfrm>
+            <a:off x="4572000" y="3621024"/>
+            <a:ext cx="6537960" cy="475488"/>
           </a:xfrm>
           <a:prstGeom prst="rect">
             <a:avLst/>
@@ -3835,28 +3791,6 @@
             </a:r>
             <a:endParaRPr lang="en-US" sz="900" dirty="0"/>
           </a:p>
-        </p:txBody>
-      </p:sp>
-      <p:sp>
-        <p:nvSpPr>
-          <p:cNvPr id="17" name="Text 14"/>
-          <p:cNvSpPr/>
-          <p:nvPr/>
-        </p:nvSpPr>
-        <p:spPr>
-          <a:xfrm>
-            <a:off x="4572000" y="4032504"/>
-            <a:ext cx="6537960" cy="36576"/>
-          </a:xfrm>
-          <a:prstGeom prst="rect">
-            <a:avLst/>
-          </a:prstGeom>
-          <a:noFill/>
-          <a:ln/>
-        </p:spPr>
-        <p:txBody>
-          <a:bodyPr wrap="square" lIns="0" tIns="0" rIns="0" bIns="0" rtlCol="0" anchor="ctr"/>
-          <a:lstStyle/>
           <a:p>
             <a:pPr indent="0" marL="0">
               <a:buNone/>
@@ -3872,13 +3806,13 @@
               </a:rPr>
               <a:t>El Tigre, estado Anzoátegui</a:t>
             </a:r>
-            <a:endParaRPr lang="en-US" sz="1400" dirty="0"/>
-          </a:p>
-        </p:txBody>
-      </p:sp>
-      <p:sp>
-        <p:nvSpPr>
-          <p:cNvPr id="18" name="Shape 15"/>
+            <a:endParaRPr lang="en-US" sz="900" dirty="0"/>
+          </a:p>
+        </p:txBody>
+      </p:sp>
+      <p:sp>
+        <p:nvSpPr>
+          <p:cNvPr id="15" name="Shape 12"/>
           <p:cNvSpPr/>
           <p:nvPr/>
         </p:nvSpPr>
@@ -3903,7 +3837,7 @@
       </p:sp>
       <p:sp>
         <p:nvSpPr>
-          <p:cNvPr id="19" name="Shape 16"/>
+          <p:cNvPr id="16" name="Shape 13"/>
           <p:cNvSpPr/>
           <p:nvPr/>
         </p:nvSpPr>
@@ -3928,14 +3862,14 @@
       </p:sp>
       <p:sp>
         <p:nvSpPr>
-          <p:cNvPr id="20" name="Text 17"/>
-          <p:cNvSpPr/>
-          <p:nvPr/>
-        </p:nvSpPr>
-        <p:spPr>
-          <a:xfrm>
-            <a:off x="4572000" y="4480560"/>
-            <a:ext cx="6537960" cy="292608"/>
+          <p:cNvPr id="17" name="Text 14"/>
+          <p:cNvSpPr/>
+          <p:nvPr/>
+        </p:nvSpPr>
+        <p:spPr>
+          <a:xfrm>
+            <a:off x="4572000" y="4425696"/>
+            <a:ext cx="6537960" cy="475488"/>
           </a:xfrm>
           <a:prstGeom prst="rect">
             <a:avLst/>
@@ -3963,28 +3897,6 @@
             </a:r>
             <a:endParaRPr lang="en-US" sz="900" dirty="0"/>
           </a:p>
-        </p:txBody>
-      </p:sp>
-      <p:sp>
-        <p:nvSpPr>
-          <p:cNvPr id="21" name="Text 18"/>
-          <p:cNvSpPr/>
-          <p:nvPr/>
-        </p:nvSpPr>
-        <p:spPr>
-          <a:xfrm>
-            <a:off x="4572000" y="4837176"/>
-            <a:ext cx="6537960" cy="36576"/>
-          </a:xfrm>
-          <a:prstGeom prst="rect">
-            <a:avLst/>
-          </a:prstGeom>
-          <a:noFill/>
-          <a:ln/>
-        </p:spPr>
-        <p:txBody>
-          <a:bodyPr wrap="square" lIns="0" tIns="0" rIns="0" bIns="0" rtlCol="0" anchor="ctr"/>
-          <a:lstStyle/>
           <a:p>
             <a:pPr indent="0" marL="0">
               <a:buNone/>
@@ -4000,13 +3912,13 @@
               </a:rPr>
               <a:t>Atención al Cliente · Semanas 1–3</a:t>
             </a:r>
-            <a:endParaRPr lang="en-US" sz="1400" dirty="0"/>
-          </a:p>
-        </p:txBody>
-      </p:sp>
-      <p:sp>
-        <p:nvSpPr>
-          <p:cNvPr id="22" name="Shape 19"/>
+            <a:endParaRPr lang="en-US" sz="900" dirty="0"/>
+          </a:p>
+        </p:txBody>
+      </p:sp>
+      <p:sp>
+        <p:nvSpPr>
+          <p:cNvPr id="18" name="Shape 15"/>
           <p:cNvSpPr/>
           <p:nvPr/>
         </p:nvSpPr>
@@ -4031,7 +3943,7 @@
       </p:sp>
       <p:sp>
         <p:nvSpPr>
-          <p:cNvPr id="23" name="Shape 20"/>
+          <p:cNvPr id="19" name="Shape 16"/>
           <p:cNvSpPr/>
           <p:nvPr/>
         </p:nvSpPr>
@@ -4056,14 +3968,14 @@
       </p:sp>
       <p:sp>
         <p:nvSpPr>
-          <p:cNvPr id="24" name="Text 21"/>
-          <p:cNvSpPr/>
-          <p:nvPr/>
-        </p:nvSpPr>
-        <p:spPr>
-          <a:xfrm>
-            <a:off x="4572000" y="5285232"/>
-            <a:ext cx="6537960" cy="292608"/>
+          <p:cNvPr id="20" name="Text 17"/>
+          <p:cNvSpPr/>
+          <p:nvPr/>
+        </p:nvSpPr>
+        <p:spPr>
+          <a:xfrm>
+            <a:off x="4572000" y="5230368"/>
+            <a:ext cx="6537960" cy="475488"/>
           </a:xfrm>
           <a:prstGeom prst="rect">
             <a:avLst/>
@@ -4091,28 +4003,6 @@
             </a:r>
             <a:endParaRPr lang="en-US" sz="900" dirty="0"/>
           </a:p>
-        </p:txBody>
-      </p:sp>
-      <p:sp>
-        <p:nvSpPr>
-          <p:cNvPr id="25" name="Text 22"/>
-          <p:cNvSpPr/>
-          <p:nvPr/>
-        </p:nvSpPr>
-        <p:spPr>
-          <a:xfrm>
-            <a:off x="4572000" y="5641848"/>
-            <a:ext cx="6537960" cy="36576"/>
-          </a:xfrm>
-          <a:prstGeom prst="rect">
-            <a:avLst/>
-          </a:prstGeom>
-          <a:noFill/>
-          <a:ln/>
-        </p:spPr>
-        <p:txBody>
-          <a:bodyPr wrap="square" lIns="0" tIns="0" rIns="0" bIns="0" rtlCol="0" anchor="ctr"/>
-          <a:lstStyle/>
           <a:p>
             <a:pPr indent="0" marL="0">
               <a:buNone/>
@@ -4128,7 +4018,7 @@
               </a:rPr>
               <a:t>Administración · Semanas 4–10</a:t>
             </a:r>
-            <a:endParaRPr lang="en-US" sz="1400" dirty="0"/>
+            <a:endParaRPr lang="en-US" sz="900" dirty="0"/>
           </a:p>
         </p:txBody>
       </p:sp>
@@ -4694,8 +4584,8 @@
         </p:nvSpPr>
         <p:spPr>
           <a:xfrm>
-            <a:off x="1143000" y="4946904"/>
-            <a:ext cx="3017520" cy="292608"/>
+            <a:off x="1143000" y="4892040"/>
+            <a:ext cx="3017520" cy="960120"/>
           </a:xfrm>
           <a:prstGeom prst="rect">
             <a:avLst/>
@@ -4723,28 +4613,6 @@
             </a:r>
             <a:endParaRPr lang="en-US" sz="1700" dirty="0"/>
           </a:p>
-        </p:txBody>
-      </p:sp>
-      <p:sp>
-        <p:nvSpPr>
-          <p:cNvPr id="18" name="Text 16"/>
-          <p:cNvSpPr/>
-          <p:nvPr/>
-        </p:nvSpPr>
-        <p:spPr>
-          <a:xfrm>
-            <a:off x="1143000" y="5303520"/>
-            <a:ext cx="3017520" cy="521208"/>
-          </a:xfrm>
-          <a:prstGeom prst="rect">
-            <a:avLst/>
-          </a:prstGeom>
-          <a:noFill/>
-          <a:ln/>
-        </p:spPr>
-        <p:txBody>
-          <a:bodyPr wrap="square" lIns="0" tIns="0" rIns="0" bIns="0" rtlCol="0" anchor="ctr"/>
-          <a:lstStyle/>
           <a:p>
             <a:pPr indent="0" marL="0">
               <a:buNone/>
@@ -4760,13 +4628,13 @@
               </a:rPr>
               <a:t>recorrido actual</a:t>
             </a:r>
-            <a:endParaRPr lang="en-US" sz="1200" dirty="0"/>
-          </a:p>
-        </p:txBody>
-      </p:sp>
-      <p:sp>
-        <p:nvSpPr>
-          <p:cNvPr id="19" name="Shape 17"/>
+            <a:endParaRPr lang="en-US" sz="1700" dirty="0"/>
+          </a:p>
+        </p:txBody>
+      </p:sp>
+      <p:sp>
+        <p:nvSpPr>
+          <p:cNvPr id="18" name="Shape 16"/>
           <p:cNvSpPr/>
           <p:nvPr/>
         </p:nvSpPr>
@@ -4791,7 +4659,7 @@
       </p:sp>
       <p:sp>
         <p:nvSpPr>
-          <p:cNvPr id="20" name="Shape 18"/>
+          <p:cNvPr id="19" name="Shape 17"/>
           <p:cNvSpPr/>
           <p:nvPr/>
         </p:nvSpPr>
@@ -4816,14 +4684,14 @@
       </p:sp>
       <p:sp>
         <p:nvSpPr>
-          <p:cNvPr id="21" name="Text 19"/>
-          <p:cNvSpPr/>
-          <p:nvPr/>
-        </p:nvSpPr>
-        <p:spPr>
-          <a:xfrm>
-            <a:off x="4846320" y="4946904"/>
-            <a:ext cx="3017520" cy="292608"/>
+          <p:cNvPr id="20" name="Text 18"/>
+          <p:cNvSpPr/>
+          <p:nvPr/>
+        </p:nvSpPr>
+        <p:spPr>
+          <a:xfrm>
+            <a:off x="4846320" y="4892040"/>
+            <a:ext cx="3017520" cy="960120"/>
           </a:xfrm>
           <a:prstGeom prst="rect">
             <a:avLst/>
@@ -4851,28 +4719,6 @@
             </a:r>
             <a:endParaRPr lang="en-US" sz="1700" dirty="0"/>
           </a:p>
-        </p:txBody>
-      </p:sp>
-      <p:sp>
-        <p:nvSpPr>
-          <p:cNvPr id="22" name="Text 20"/>
-          <p:cNvSpPr/>
-          <p:nvPr/>
-        </p:nvSpPr>
-        <p:spPr>
-          <a:xfrm>
-            <a:off x="4846320" y="5303520"/>
-            <a:ext cx="3017520" cy="521208"/>
-          </a:xfrm>
-          <a:prstGeom prst="rect">
-            <a:avLst/>
-          </a:prstGeom>
-          <a:noFill/>
-          <a:ln/>
-        </p:spPr>
-        <p:txBody>
-          <a:bodyPr wrap="square" lIns="0" tIns="0" rIns="0" bIns="0" rtlCol="0" anchor="ctr"/>
-          <a:lstStyle/>
           <a:p>
             <a:pPr indent="0" marL="0">
               <a:buNone/>
@@ -4888,13 +4734,13 @@
               </a:rPr>
               <a:t>deficiencias y causas</a:t>
             </a:r>
-            <a:endParaRPr lang="en-US" sz="1200" dirty="0"/>
-          </a:p>
-        </p:txBody>
-      </p:sp>
-      <p:sp>
-        <p:nvSpPr>
-          <p:cNvPr id="23" name="Shape 21"/>
+            <a:endParaRPr lang="en-US" sz="1700" dirty="0"/>
+          </a:p>
+        </p:txBody>
+      </p:sp>
+      <p:sp>
+        <p:nvSpPr>
+          <p:cNvPr id="21" name="Shape 19"/>
           <p:cNvSpPr/>
           <p:nvPr/>
         </p:nvSpPr>
@@ -4919,7 +4765,7 @@
       </p:sp>
       <p:sp>
         <p:nvSpPr>
-          <p:cNvPr id="24" name="Shape 22"/>
+          <p:cNvPr id="22" name="Shape 20"/>
           <p:cNvSpPr/>
           <p:nvPr/>
         </p:nvSpPr>
@@ -4944,14 +4790,14 @@
       </p:sp>
       <p:sp>
         <p:nvSpPr>
-          <p:cNvPr id="25" name="Text 23"/>
-          <p:cNvSpPr/>
-          <p:nvPr/>
-        </p:nvSpPr>
-        <p:spPr>
-          <a:xfrm>
-            <a:off x="8549640" y="4946904"/>
-            <a:ext cx="3017520" cy="292608"/>
+          <p:cNvPr id="23" name="Text 21"/>
+          <p:cNvSpPr/>
+          <p:nvPr/>
+        </p:nvSpPr>
+        <p:spPr>
+          <a:xfrm>
+            <a:off x="8549640" y="4892040"/>
+            <a:ext cx="3017520" cy="960120"/>
           </a:xfrm>
           <a:prstGeom prst="rect">
             <a:avLst/>
@@ -4979,28 +4825,6 @@
             </a:r>
             <a:endParaRPr lang="en-US" sz="1700" dirty="0"/>
           </a:p>
-        </p:txBody>
-      </p:sp>
-      <p:sp>
-        <p:nvSpPr>
-          <p:cNvPr id="26" name="Text 24"/>
-          <p:cNvSpPr/>
-          <p:nvPr/>
-        </p:nvSpPr>
-        <p:spPr>
-          <a:xfrm>
-            <a:off x="8549640" y="5303520"/>
-            <a:ext cx="3017520" cy="521208"/>
-          </a:xfrm>
-          <a:prstGeom prst="rect">
-            <a:avLst/>
-          </a:prstGeom>
-          <a:noFill/>
-          <a:ln/>
-        </p:spPr>
-        <p:txBody>
-          <a:bodyPr wrap="square" lIns="0" tIns="0" rIns="0" bIns="0" rtlCol="0" anchor="ctr"/>
-          <a:lstStyle/>
           <a:p>
             <a:pPr indent="0" marL="0">
               <a:buNone/>
@@ -5016,7 +4840,7 @@
               </a:rPr>
               <a:t>mejoras procedimentales</a:t>
             </a:r>
-            <a:endParaRPr lang="en-US" sz="1200" dirty="0"/>
+            <a:endParaRPr lang="en-US" sz="1700" dirty="0"/>
           </a:p>
         </p:txBody>
       </p:sp>
@@ -5443,8 +5267,8 @@
         </p:blipFill>
         <p:spPr>
           <a:xfrm>
-            <a:off x="3977640" y="1737360"/>
-            <a:ext cx="7452360" cy="3794760"/>
+            <a:off x="5872441" y="1737360"/>
+            <a:ext cx="3662758" cy="3337560"/>
           </a:xfrm>
           <a:prstGeom prst="rect">
             <a:avLst/>
@@ -5721,8 +5545,8 @@
         </p:nvSpPr>
         <p:spPr>
           <a:xfrm>
-            <a:off x="914400" y="2020824"/>
-            <a:ext cx="4846320" cy="292608"/>
+            <a:off x="914400" y="1965960"/>
+            <a:ext cx="4846320" cy="896112"/>
           </a:xfrm>
           <a:prstGeom prst="rect">
             <a:avLst/>
@@ -5750,28 +5574,6 @@
             </a:r>
             <a:endParaRPr lang="en-US" sz="1500" dirty="0"/>
           </a:p>
-        </p:txBody>
-      </p:sp>
-      <p:sp>
-        <p:nvSpPr>
-          <p:cNvPr id="7" name="Text 5"/>
-          <p:cNvSpPr/>
-          <p:nvPr/>
-        </p:nvSpPr>
-        <p:spPr>
-          <a:xfrm>
-            <a:off x="914400" y="2377440"/>
-            <a:ext cx="4846320" cy="457200"/>
-          </a:xfrm>
-          <a:prstGeom prst="rect">
-            <a:avLst/>
-          </a:prstGeom>
-          <a:noFill/>
-          <a:ln/>
-        </p:spPr>
-        <p:txBody>
-          <a:bodyPr wrap="square" lIns="0" tIns="0" rIns="0" bIns="0" rtlCol="0" anchor="ctr"/>
-          <a:lstStyle/>
           <a:p>
             <a:pPr indent="0" marL="0">
               <a:buNone/>
@@ -5787,13 +5589,13 @@
               </a:rPr>
               <a:t>Verificar el proceso y corregir desviaciones.</a:t>
             </a:r>
-            <a:endParaRPr lang="en-US" sz="1100" dirty="0"/>
-          </a:p>
-        </p:txBody>
-      </p:sp>
-      <p:sp>
-        <p:nvSpPr>
-          <p:cNvPr id="8" name="Shape 6"/>
+            <a:endParaRPr lang="en-US" sz="1500" dirty="0"/>
+          </a:p>
+        </p:txBody>
+      </p:sp>
+      <p:sp>
+        <p:nvSpPr>
+          <p:cNvPr id="7" name="Shape 5"/>
           <p:cNvSpPr/>
           <p:nvPr/>
         </p:nvSpPr>
@@ -5818,7 +5620,7 @@
       </p:sp>
       <p:sp>
         <p:nvSpPr>
-          <p:cNvPr id="9" name="Shape 7"/>
+          <p:cNvPr id="8" name="Shape 6"/>
           <p:cNvSpPr/>
           <p:nvPr/>
         </p:nvSpPr>
@@ -5843,14 +5645,14 @@
       </p:sp>
       <p:sp>
         <p:nvSpPr>
-          <p:cNvPr id="10" name="Text 8"/>
-          <p:cNvSpPr/>
-          <p:nvPr/>
-        </p:nvSpPr>
-        <p:spPr>
-          <a:xfrm>
-            <a:off x="6309360" y="2020824"/>
-            <a:ext cx="4846320" cy="292608"/>
+          <p:cNvPr id="9" name="Text 7"/>
+          <p:cNvSpPr/>
+          <p:nvPr/>
+        </p:nvSpPr>
+        <p:spPr>
+          <a:xfrm>
+            <a:off x="6309360" y="1965960"/>
+            <a:ext cx="4846320" cy="896112"/>
           </a:xfrm>
           <a:prstGeom prst="rect">
             <a:avLst/>
@@ -5878,28 +5680,6 @@
             </a:r>
             <a:endParaRPr lang="en-US" sz="1500" dirty="0"/>
           </a:p>
-        </p:txBody>
-      </p:sp>
-      <p:sp>
-        <p:nvSpPr>
-          <p:cNvPr id="11" name="Text 9"/>
-          <p:cNvSpPr/>
-          <p:nvPr/>
-        </p:nvSpPr>
-        <p:spPr>
-          <a:xfrm>
-            <a:off x="6309360" y="2377440"/>
-            <a:ext cx="4846320" cy="457200"/>
-          </a:xfrm>
-          <a:prstGeom prst="rect">
-            <a:avLst/>
-          </a:prstGeom>
-          <a:noFill/>
-          <a:ln/>
-        </p:spPr>
-        <p:txBody>
-          <a:bodyPr wrap="square" lIns="0" tIns="0" rIns="0" bIns="0" rtlCol="0" anchor="ctr"/>
-          <a:lstStyle/>
           <a:p>
             <a:pPr indent="0" marL="0">
               <a:buNone/>
@@ -5915,13 +5695,13 @@
               </a:rPr>
               <a:t>Recibir, registrar, procesar, seguir y cerrar.</a:t>
             </a:r>
-            <a:endParaRPr lang="en-US" sz="1100" dirty="0"/>
-          </a:p>
-        </p:txBody>
-      </p:sp>
-      <p:sp>
-        <p:nvSpPr>
-          <p:cNvPr id="12" name="Shape 10"/>
+            <a:endParaRPr lang="en-US" sz="1500" dirty="0"/>
+          </a:p>
+        </p:txBody>
+      </p:sp>
+      <p:sp>
+        <p:nvSpPr>
+          <p:cNvPr id="10" name="Shape 8"/>
           <p:cNvSpPr/>
           <p:nvPr/>
         </p:nvSpPr>
@@ -5946,7 +5726,7 @@
       </p:sp>
       <p:sp>
         <p:nvSpPr>
-          <p:cNvPr id="13" name="Shape 11"/>
+          <p:cNvPr id="11" name="Shape 9"/>
           <p:cNvSpPr/>
           <p:nvPr/>
         </p:nvSpPr>
@@ -5971,14 +5751,14 @@
       </p:sp>
       <p:sp>
         <p:nvSpPr>
-          <p:cNvPr id="14" name="Text 12"/>
-          <p:cNvSpPr/>
-          <p:nvPr/>
-        </p:nvSpPr>
-        <p:spPr>
-          <a:xfrm>
-            <a:off x="914400" y="3392424"/>
-            <a:ext cx="4846320" cy="292608"/>
+          <p:cNvPr id="12" name="Text 10"/>
+          <p:cNvSpPr/>
+          <p:nvPr/>
+        </p:nvSpPr>
+        <p:spPr>
+          <a:xfrm>
+            <a:off x="914400" y="3337560"/>
+            <a:ext cx="4846320" cy="896112"/>
           </a:xfrm>
           <a:prstGeom prst="rect">
             <a:avLst/>
@@ -6006,28 +5786,6 @@
             </a:r>
             <a:endParaRPr lang="en-US" sz="1500" dirty="0"/>
           </a:p>
-        </p:txBody>
-      </p:sp>
-      <p:sp>
-        <p:nvSpPr>
-          <p:cNvPr id="15" name="Text 13"/>
-          <p:cNvSpPr/>
-          <p:nvPr/>
-        </p:nvSpPr>
-        <p:spPr>
-          <a:xfrm>
-            <a:off x="914400" y="3749040"/>
-            <a:ext cx="4846320" cy="457200"/>
-          </a:xfrm>
-          <a:prstGeom prst="rect">
-            <a:avLst/>
-          </a:prstGeom>
-          <a:noFill/>
-          <a:ln/>
-        </p:spPr>
-        <p:txBody>
-          <a:bodyPr wrap="square" lIns="0" tIns="0" rIns="0" bIns="0" rtlCol="0" anchor="ctr"/>
-          <a:lstStyle/>
           <a:p>
             <a:pPr indent="0" marL="0">
               <a:buNone/>
@@ -6043,13 +5801,13 @@
               </a:rPr>
               <a:t>Reconstruir el recorrido completo de un caso.</a:t>
             </a:r>
-            <a:endParaRPr lang="en-US" sz="1100" dirty="0"/>
-          </a:p>
-        </p:txBody>
-      </p:sp>
-      <p:sp>
-        <p:nvSpPr>
-          <p:cNvPr id="16" name="Shape 14"/>
+            <a:endParaRPr lang="en-US" sz="1500" dirty="0"/>
+          </a:p>
+        </p:txBody>
+      </p:sp>
+      <p:sp>
+        <p:nvSpPr>
+          <p:cNvPr id="13" name="Shape 11"/>
           <p:cNvSpPr/>
           <p:nvPr/>
         </p:nvSpPr>
@@ -6074,7 +5832,7 @@
       </p:sp>
       <p:sp>
         <p:nvSpPr>
-          <p:cNvPr id="17" name="Shape 15"/>
+          <p:cNvPr id="14" name="Shape 12"/>
           <p:cNvSpPr/>
           <p:nvPr/>
         </p:nvSpPr>
@@ -6099,14 +5857,14 @@
       </p:sp>
       <p:sp>
         <p:nvSpPr>
-          <p:cNvPr id="18" name="Text 16"/>
-          <p:cNvSpPr/>
-          <p:nvPr/>
-        </p:nvSpPr>
-        <p:spPr>
-          <a:xfrm>
-            <a:off x="6309360" y="3392424"/>
-            <a:ext cx="4846320" cy="292608"/>
+          <p:cNvPr id="15" name="Text 13"/>
+          <p:cNvSpPr/>
+          <p:nvPr/>
+        </p:nvSpPr>
+        <p:spPr>
+          <a:xfrm>
+            <a:off x="6309360" y="3337560"/>
+            <a:ext cx="4846320" cy="896112"/>
           </a:xfrm>
           <a:prstGeom prst="rect">
             <a:avLst/>
@@ -6134,28 +5892,6 @@
             </a:r>
             <a:endParaRPr lang="en-US" sz="1500" dirty="0"/>
           </a:p>
-        </p:txBody>
-      </p:sp>
-      <p:sp>
-        <p:nvSpPr>
-          <p:cNvPr id="19" name="Text 17"/>
-          <p:cNvSpPr/>
-          <p:nvPr/>
-        </p:nvSpPr>
-        <p:spPr>
-          <a:xfrm>
-            <a:off x="6309360" y="3749040"/>
-            <a:ext cx="4846320" cy="457200"/>
-          </a:xfrm>
-          <a:prstGeom prst="rect">
-            <a:avLst/>
-          </a:prstGeom>
-          <a:noFill/>
-          <a:ln/>
-        </p:spPr>
-        <p:txBody>
-          <a:bodyPr wrap="square" lIns="0" tIns="0" rIns="0" bIns="0" rtlCol="0" anchor="ctr"/>
-          <a:lstStyle/>
           <a:p>
             <a:pPr indent="0" marL="0">
               <a:buNone/>
@@ -6171,13 +5907,13 @@
               </a:rPr>
               <a:t>Aplicar criterios, estados y formatos comunes.</a:t>
             </a:r>
-            <a:endParaRPr lang="en-US" sz="1100" dirty="0"/>
-          </a:p>
-        </p:txBody>
-      </p:sp>
-      <p:sp>
-        <p:nvSpPr>
-          <p:cNvPr id="20" name="Shape 18"/>
+            <a:endParaRPr lang="en-US" sz="1500" dirty="0"/>
+          </a:p>
+        </p:txBody>
+      </p:sp>
+      <p:sp>
+        <p:nvSpPr>
+          <p:cNvPr id="16" name="Shape 14"/>
           <p:cNvSpPr/>
           <p:nvPr/>
         </p:nvSpPr>
@@ -6202,7 +5938,7 @@
       </p:sp>
       <p:sp>
         <p:nvSpPr>
-          <p:cNvPr id="21" name="Shape 19"/>
+          <p:cNvPr id="17" name="Shape 15"/>
           <p:cNvSpPr/>
           <p:nvPr/>
         </p:nvSpPr>
@@ -6227,14 +5963,14 @@
       </p:sp>
       <p:sp>
         <p:nvSpPr>
-          <p:cNvPr id="22" name="Text 20"/>
-          <p:cNvSpPr/>
-          <p:nvPr/>
-        </p:nvSpPr>
-        <p:spPr>
-          <a:xfrm>
-            <a:off x="914400" y="5038344"/>
-            <a:ext cx="4846320" cy="292608"/>
+          <p:cNvPr id="18" name="Text 16"/>
+          <p:cNvSpPr/>
+          <p:nvPr/>
+        </p:nvSpPr>
+        <p:spPr>
+          <a:xfrm>
+            <a:off x="914400" y="4983480"/>
+            <a:ext cx="4846320" cy="731520"/>
           </a:xfrm>
           <a:prstGeom prst="rect">
             <a:avLst/>
@@ -6262,28 +5998,6 @@
             </a:r>
             <a:endParaRPr lang="en-US" sz="1300" dirty="0"/>
           </a:p>
-        </p:txBody>
-      </p:sp>
-      <p:sp>
-        <p:nvSpPr>
-          <p:cNvPr id="23" name="Text 21"/>
-          <p:cNvSpPr/>
-          <p:nvPr/>
-        </p:nvSpPr>
-        <p:spPr>
-          <a:xfrm>
-            <a:off x="914400" y="5394960"/>
-            <a:ext cx="4846320" cy="292608"/>
-          </a:xfrm>
-          <a:prstGeom prst="rect">
-            <a:avLst/>
-          </a:prstGeom>
-          <a:noFill/>
-          <a:ln/>
-        </p:spPr>
-        <p:txBody>
-          <a:bodyPr wrap="square" lIns="0" tIns="0" rIns="0" bIns="0" rtlCol="0" anchor="ctr"/>
-          <a:lstStyle/>
           <a:p>
             <a:pPr indent="0" marL="0">
               <a:buNone/>
@@ -6299,13 +6013,13 @@
               </a:rPr>
               <a:t>Marco general de la actividad económica.</a:t>
             </a:r>
-            <a:endParaRPr lang="en-US" sz="1000" dirty="0"/>
-          </a:p>
-        </p:txBody>
-      </p:sp>
-      <p:sp>
-        <p:nvSpPr>
-          <p:cNvPr id="24" name="Shape 22"/>
+            <a:endParaRPr lang="en-US" sz="1300" dirty="0"/>
+          </a:p>
+        </p:txBody>
+      </p:sp>
+      <p:sp>
+        <p:nvSpPr>
+          <p:cNvPr id="19" name="Shape 17"/>
           <p:cNvSpPr/>
           <p:nvPr/>
         </p:nvSpPr>
@@ -6330,7 +6044,7 @@
       </p:sp>
       <p:sp>
         <p:nvSpPr>
-          <p:cNvPr id="25" name="Shape 23"/>
+          <p:cNvPr id="20" name="Shape 18"/>
           <p:cNvSpPr/>
           <p:nvPr/>
         </p:nvSpPr>
@@ -6355,14 +6069,14 @@
       </p:sp>
       <p:sp>
         <p:nvSpPr>
-          <p:cNvPr id="26" name="Text 24"/>
-          <p:cNvSpPr/>
-          <p:nvPr/>
-        </p:nvSpPr>
-        <p:spPr>
-          <a:xfrm>
-            <a:off x="6309360" y="5038344"/>
-            <a:ext cx="4846320" cy="292608"/>
+          <p:cNvPr id="21" name="Text 19"/>
+          <p:cNvSpPr/>
+          <p:nvPr/>
+        </p:nvSpPr>
+        <p:spPr>
+          <a:xfrm>
+            <a:off x="6309360" y="4983480"/>
+            <a:ext cx="4846320" cy="731520"/>
           </a:xfrm>
           <a:prstGeom prst="rect">
             <a:avLst/>
@@ -6390,28 +6104,6 @@
             </a:r>
             <a:endParaRPr lang="en-US" sz="1300" dirty="0"/>
           </a:p>
-        </p:txBody>
-      </p:sp>
-      <p:sp>
-        <p:nvSpPr>
-          <p:cNvPr id="27" name="Text 25"/>
-          <p:cNvSpPr/>
-          <p:nvPr/>
-        </p:nvSpPr>
-        <p:spPr>
-          <a:xfrm>
-            <a:off x="6309360" y="5394960"/>
-            <a:ext cx="4846320" cy="292608"/>
-          </a:xfrm>
-          <a:prstGeom prst="rect">
-            <a:avLst/>
-          </a:prstGeom>
-          <a:noFill/>
-          <a:ln/>
-        </p:spPr>
-        <p:txBody>
-          <a:bodyPr wrap="square" lIns="0" tIns="0" rIns="0" bIns="0" rtlCol="0" anchor="ctr"/>
-          <a:lstStyle/>
           <a:p>
             <a:pPr indent="0" marL="0">
               <a:buNone/>
@@ -6427,7 +6119,7 @@
               </a:rPr>
               <a:t>Orden y claridad de los registros.</a:t>
             </a:r>
-            <a:endParaRPr lang="en-US" sz="1000" dirty="0"/>
+            <a:endParaRPr lang="en-US" sz="1300" dirty="0"/>
           </a:p>
         </p:txBody>
       </p:sp>
@@ -6640,8 +6332,8 @@
         </p:nvSpPr>
         <p:spPr>
           <a:xfrm>
-            <a:off x="960120" y="2386584"/>
-            <a:ext cx="4754880" cy="292608"/>
+            <a:off x="960120" y="2331720"/>
+            <a:ext cx="4754880" cy="1234440"/>
           </a:xfrm>
           <a:prstGeom prst="rect">
             <a:avLst/>
@@ -6669,28 +6361,6 @@
             </a:r>
             <a:endParaRPr lang="en-US" sz="1600" dirty="0"/>
           </a:p>
-        </p:txBody>
-      </p:sp>
-      <p:sp>
-        <p:nvSpPr>
-          <p:cNvPr id="7" name="Text 5"/>
-          <p:cNvSpPr/>
-          <p:nvPr/>
-        </p:nvSpPr>
-        <p:spPr>
-          <a:xfrm>
-            <a:off x="960120" y="2743200"/>
-            <a:ext cx="4754880" cy="795528"/>
-          </a:xfrm>
-          <a:prstGeom prst="rect">
-            <a:avLst/>
-          </a:prstGeom>
-          <a:noFill/>
-          <a:ln/>
-        </p:spPr>
-        <p:txBody>
-          <a:bodyPr wrap="square" lIns="0" tIns="0" rIns="0" bIns="0" rtlCol="0" anchor="ctr"/>
-          <a:lstStyle/>
           <a:p>
             <a:pPr indent="0" marL="0">
               <a:buNone/>
@@ -6706,13 +6376,13 @@
               </a:rPr>
               <a:t>Atención al Cliente y Administración.</a:t>
             </a:r>
-            <a:endParaRPr lang="en-US" sz="1200" dirty="0"/>
-          </a:p>
-        </p:txBody>
-      </p:sp>
-      <p:sp>
-        <p:nvSpPr>
-          <p:cNvPr id="8" name="Shape 6"/>
+            <a:endParaRPr lang="en-US" sz="1600" dirty="0"/>
+          </a:p>
+        </p:txBody>
+      </p:sp>
+      <p:sp>
+        <p:nvSpPr>
+          <p:cNvPr id="7" name="Shape 5"/>
           <p:cNvSpPr/>
           <p:nvPr/>
         </p:nvSpPr>
@@ -6737,7 +6407,7 @@
       </p:sp>
       <p:sp>
         <p:nvSpPr>
-          <p:cNvPr id="9" name="Shape 7"/>
+          <p:cNvPr id="8" name="Shape 6"/>
           <p:cNvSpPr/>
           <p:nvPr/>
         </p:nvSpPr>
@@ -6762,14 +6432,14 @@
       </p:sp>
       <p:sp>
         <p:nvSpPr>
-          <p:cNvPr id="10" name="Text 8"/>
-          <p:cNvSpPr/>
-          <p:nvPr/>
-        </p:nvSpPr>
-        <p:spPr>
-          <a:xfrm>
-            <a:off x="6355080" y="2386584"/>
-            <a:ext cx="4754880" cy="292608"/>
+          <p:cNvPr id="9" name="Text 7"/>
+          <p:cNvSpPr/>
+          <p:nvPr/>
+        </p:nvSpPr>
+        <p:spPr>
+          <a:xfrm>
+            <a:off x="6355080" y="2331720"/>
+            <a:ext cx="4754880" cy="1234440"/>
           </a:xfrm>
           <a:prstGeom prst="rect">
             <a:avLst/>
@@ -6797,28 +6467,6 @@
             </a:r>
             <a:endParaRPr lang="en-US" sz="1600" dirty="0"/>
           </a:p>
-        </p:txBody>
-      </p:sp>
-      <p:sp>
-        <p:nvSpPr>
-          <p:cNvPr id="11" name="Text 9"/>
-          <p:cNvSpPr/>
-          <p:nvPr/>
-        </p:nvSpPr>
-        <p:spPr>
-          <a:xfrm>
-            <a:off x="6355080" y="2743200"/>
-            <a:ext cx="4754880" cy="795528"/>
-          </a:xfrm>
-          <a:prstGeom prst="rect">
-            <a:avLst/>
-          </a:prstGeom>
-          <a:noFill/>
-          <a:ln/>
-        </p:spPr>
-        <p:txBody>
-          <a:bodyPr wrap="square" lIns="0" tIns="0" rIns="0" bIns="0" rtlCol="0" anchor="ctr"/>
-          <a:lstStyle/>
           <a:p>
             <a:pPr indent="0" marL="0">
               <a:buNone/>
@@ -6834,13 +6482,13 @@
               </a:rPr>
               <a:t>Registros, personal e identificación de fallas.</a:t>
             </a:r>
-            <a:endParaRPr lang="en-US" sz="1200" dirty="0"/>
-          </a:p>
-        </p:txBody>
-      </p:sp>
-      <p:sp>
-        <p:nvSpPr>
-          <p:cNvPr id="12" name="Shape 10"/>
+            <a:endParaRPr lang="en-US" sz="1600" dirty="0"/>
+          </a:p>
+        </p:txBody>
+      </p:sp>
+      <p:sp>
+        <p:nvSpPr>
+          <p:cNvPr id="10" name="Shape 8"/>
           <p:cNvSpPr/>
           <p:nvPr/>
         </p:nvSpPr>
@@ -6865,7 +6513,7 @@
       </p:sp>
       <p:sp>
         <p:nvSpPr>
-          <p:cNvPr id="13" name="Shape 11"/>
+          <p:cNvPr id="11" name="Shape 9"/>
           <p:cNvSpPr/>
           <p:nvPr/>
         </p:nvSpPr>
@@ -6890,14 +6538,14 @@
       </p:sp>
       <p:sp>
         <p:nvSpPr>
-          <p:cNvPr id="14" name="Text 12"/>
-          <p:cNvSpPr/>
-          <p:nvPr/>
-        </p:nvSpPr>
-        <p:spPr>
-          <a:xfrm>
-            <a:off x="960120" y="4261104"/>
-            <a:ext cx="4754880" cy="292608"/>
+          <p:cNvPr id="12" name="Text 10"/>
+          <p:cNvSpPr/>
+          <p:nvPr/>
+        </p:nvSpPr>
+        <p:spPr>
+          <a:xfrm>
+            <a:off x="960120" y="4206240"/>
+            <a:ext cx="4754880" cy="1234440"/>
           </a:xfrm>
           <a:prstGeom prst="rect">
             <a:avLst/>
@@ -6925,28 +6573,6 @@
             </a:r>
             <a:endParaRPr lang="en-US" sz="1600" dirty="0"/>
           </a:p>
-        </p:txBody>
-      </p:sp>
-      <p:sp>
-        <p:nvSpPr>
-          <p:cNvPr id="15" name="Text 13"/>
-          <p:cNvSpPr/>
-          <p:nvPr/>
-        </p:nvSpPr>
-        <p:spPr>
-          <a:xfrm>
-            <a:off x="960120" y="4617720"/>
-            <a:ext cx="4754880" cy="795528"/>
-          </a:xfrm>
-          <a:prstGeom prst="rect">
-            <a:avLst/>
-          </a:prstGeom>
-          <a:noFill/>
-          <a:ln/>
-        </p:spPr>
-        <p:txBody>
-          <a:bodyPr wrap="square" lIns="0" tIns="0" rIns="0" bIns="0" rtlCol="0" anchor="ctr"/>
-          <a:lstStyle/>
           <a:p>
             <a:pPr indent="0" marL="0">
               <a:buNone/>
@@ -6962,13 +6588,13 @@
               </a:rPr>
               <a:t>Organización de causas relacionadas.</a:t>
             </a:r>
-            <a:endParaRPr lang="en-US" sz="1200" dirty="0"/>
-          </a:p>
-        </p:txBody>
-      </p:sp>
-      <p:sp>
-        <p:nvSpPr>
-          <p:cNvPr id="16" name="Shape 14"/>
+            <a:endParaRPr lang="en-US" sz="1600" dirty="0"/>
+          </a:p>
+        </p:txBody>
+      </p:sp>
+      <p:sp>
+        <p:nvSpPr>
+          <p:cNvPr id="13" name="Shape 11"/>
           <p:cNvSpPr/>
           <p:nvPr/>
         </p:nvSpPr>
@@ -6993,7 +6619,7 @@
       </p:sp>
       <p:sp>
         <p:nvSpPr>
-          <p:cNvPr id="17" name="Shape 15"/>
+          <p:cNvPr id="14" name="Shape 12"/>
           <p:cNvSpPr/>
           <p:nvPr/>
         </p:nvSpPr>
@@ -7018,14 +6644,14 @@
       </p:sp>
       <p:sp>
         <p:nvSpPr>
-          <p:cNvPr id="18" name="Text 16"/>
-          <p:cNvSpPr/>
-          <p:nvPr/>
-        </p:nvSpPr>
-        <p:spPr>
-          <a:xfrm>
-            <a:off x="6355080" y="4261104"/>
-            <a:ext cx="4754880" cy="292608"/>
+          <p:cNvPr id="15" name="Text 13"/>
+          <p:cNvSpPr/>
+          <p:nvPr/>
+        </p:nvSpPr>
+        <p:spPr>
+          <a:xfrm>
+            <a:off x="6355080" y="4206240"/>
+            <a:ext cx="4754880" cy="1234440"/>
           </a:xfrm>
           <a:prstGeom prst="rect">
             <a:avLst/>
@@ -7053,28 +6679,6 @@
             </a:r>
             <a:endParaRPr lang="en-US" sz="1600" dirty="0"/>
           </a:p>
-        </p:txBody>
-      </p:sp>
-      <p:sp>
-        <p:nvSpPr>
-          <p:cNvPr id="19" name="Text 17"/>
-          <p:cNvSpPr/>
-          <p:nvPr/>
-        </p:nvSpPr>
-        <p:spPr>
-          <a:xfrm>
-            <a:off x="6355080" y="4617720"/>
-            <a:ext cx="4754880" cy="795528"/>
-          </a:xfrm>
-          <a:prstGeom prst="rect">
-            <a:avLst/>
-          </a:prstGeom>
-          <a:noFill/>
-          <a:ln/>
-        </p:spPr>
-        <p:txBody>
-          <a:bodyPr wrap="square" lIns="0" tIns="0" rIns="0" bIns="0" rtlCol="0" anchor="ctr"/>
-          <a:lstStyle/>
           <a:p>
             <a:pPr indent="0" marL="0">
               <a:buNone/>
@@ -7090,7 +6694,7 @@
               </a:rPr>
               <a:t>Flujo, formatos, responsables e indicadores.</a:t>
             </a:r>
-            <a:endParaRPr lang="en-US" sz="1200" dirty="0"/>
+            <a:endParaRPr lang="en-US" sz="1600" dirty="0"/>
           </a:p>
         </p:txBody>
       </p:sp>
@@ -7253,8 +6857,8 @@
         </p:nvSpPr>
         <p:spPr>
           <a:xfrm>
-            <a:off x="685800" y="1600200"/>
-            <a:ext cx="3456432" cy="713232"/>
+            <a:off x="685800" y="1664208"/>
+            <a:ext cx="3063240" cy="530352"/>
           </a:xfrm>
           <a:prstGeom prst="rect">
             <a:avLst/>
@@ -7278,8 +6882,8 @@
         </p:nvSpPr>
         <p:spPr>
           <a:xfrm>
-            <a:off x="795528" y="1709928"/>
-            <a:ext cx="3236976" cy="493776"/>
+            <a:off x="795528" y="1773936"/>
+            <a:ext cx="2843784" cy="310896"/>
           </a:xfrm>
           <a:prstGeom prst="rect">
             <a:avLst/>
@@ -7317,8 +6921,8 @@
         </p:nvSpPr>
         <p:spPr>
           <a:xfrm>
-            <a:off x="4416552" y="1600200"/>
-            <a:ext cx="3456432" cy="713232"/>
+            <a:off x="685800" y="2322576"/>
+            <a:ext cx="3063240" cy="530352"/>
           </a:xfrm>
           <a:prstGeom prst="rect">
             <a:avLst/>
@@ -7342,8 +6946,8 @@
         </p:nvSpPr>
         <p:spPr>
           <a:xfrm>
-            <a:off x="4526280" y="1709928"/>
-            <a:ext cx="3236976" cy="493776"/>
+            <a:off x="795528" y="2432304"/>
+            <a:ext cx="2843784" cy="310896"/>
           </a:xfrm>
           <a:prstGeom prst="rect">
             <a:avLst/>
@@ -7381,8 +6985,8 @@
         </p:nvSpPr>
         <p:spPr>
           <a:xfrm>
-            <a:off x="8147304" y="1600200"/>
-            <a:ext cx="3456432" cy="713232"/>
+            <a:off x="685800" y="2980944"/>
+            <a:ext cx="3063240" cy="530352"/>
           </a:xfrm>
           <a:prstGeom prst="rect">
             <a:avLst/>
@@ -7406,8 +7010,8 @@
         </p:nvSpPr>
         <p:spPr>
           <a:xfrm>
-            <a:off x="8257032" y="1709928"/>
-            <a:ext cx="3236976" cy="493776"/>
+            <a:off x="795528" y="3090672"/>
+            <a:ext cx="2843784" cy="310896"/>
           </a:xfrm>
           <a:prstGeom prst="rect">
             <a:avLst/>
@@ -7445,8 +7049,8 @@
         </p:nvSpPr>
         <p:spPr>
           <a:xfrm>
-            <a:off x="685800" y="2560320"/>
-            <a:ext cx="3456432" cy="713232"/>
+            <a:off x="685800" y="3639312"/>
+            <a:ext cx="3063240" cy="530352"/>
           </a:xfrm>
           <a:prstGeom prst="rect">
             <a:avLst/>
@@ -7470,8 +7074,8 @@
         </p:nvSpPr>
         <p:spPr>
           <a:xfrm>
-            <a:off x="795528" y="2670048"/>
-            <a:ext cx="3236976" cy="493776"/>
+            <a:off x="795528" y="3749040"/>
+            <a:ext cx="2843784" cy="310896"/>
           </a:xfrm>
           <a:prstGeom prst="rect">
             <a:avLst/>
@@ -7509,8 +7113,8 @@
         </p:nvSpPr>
         <p:spPr>
           <a:xfrm>
-            <a:off x="4416552" y="2560320"/>
-            <a:ext cx="3456432" cy="713232"/>
+            <a:off x="685800" y="4297680"/>
+            <a:ext cx="3063240" cy="530352"/>
           </a:xfrm>
           <a:prstGeom prst="rect">
             <a:avLst/>
@@ -7534,8 +7138,8 @@
         </p:nvSpPr>
         <p:spPr>
           <a:xfrm>
-            <a:off x="4526280" y="2670048"/>
-            <a:ext cx="3236976" cy="493776"/>
+            <a:off x="795528" y="4407408"/>
+            <a:ext cx="2843784" cy="310896"/>
           </a:xfrm>
           <a:prstGeom prst="rect">
             <a:avLst/>
@@ -7573,8 +7177,8 @@
         </p:nvSpPr>
         <p:spPr>
           <a:xfrm>
-            <a:off x="8147304" y="2560320"/>
-            <a:ext cx="3456432" cy="713232"/>
+            <a:off x="685800" y="4956048"/>
+            <a:ext cx="3063240" cy="530352"/>
           </a:xfrm>
           <a:prstGeom prst="rect">
             <a:avLst/>
@@ -7598,8 +7202,8 @@
         </p:nvSpPr>
         <p:spPr>
           <a:xfrm>
-            <a:off x="8257032" y="2670048"/>
-            <a:ext cx="3236976" cy="493776"/>
+            <a:off x="795528" y="5065776"/>
+            <a:ext cx="2843784" cy="310896"/>
           </a:xfrm>
           <a:prstGeom prst="rect">
             <a:avLst/>
@@ -7645,8 +7249,8 @@
         </p:blipFill>
         <p:spPr>
           <a:xfrm>
-            <a:off x="1051560" y="3657600"/>
-            <a:ext cx="10058400" cy="1600200"/>
+            <a:off x="4385394" y="1664208"/>
+            <a:ext cx="6499692" cy="3794760"/>
           </a:xfrm>
           <a:prstGeom prst="rect">
             <a:avLst/>
@@ -7661,8 +7265,8 @@
         </p:nvSpPr>
         <p:spPr>
           <a:xfrm>
-            <a:off x="914400" y="5394960"/>
-            <a:ext cx="10378440" cy="274320"/>
+            <a:off x="3977640" y="5577840"/>
+            <a:ext cx="7315200" cy="274320"/>
           </a:xfrm>
           <a:prstGeom prst="rect">
             <a:avLst/>
@@ -7678,14 +7282,14 @@
               <a:buNone/>
             </a:pPr>
             <a:r>
-              <a:rPr lang="en-US" sz="1200" b="1" dirty="0">
+              <a:rPr lang="en-US" sz="1000" b="1" dirty="0">
                 <a:solidFill>
                   <a:srgbClr val="5B2A86"/>
                 </a:solidFill>
               </a:rPr>
               <a:t>Recibida → Registrada → Asignada → En atención → Resuelta → Cerrada</a:t>
             </a:r>
-            <a:endParaRPr lang="en-US" sz="1200" dirty="0"/>
+            <a:endParaRPr lang="en-US" sz="1000" dirty="0"/>
           </a:p>
         </p:txBody>
       </p:sp>
@@ -7697,7 +7301,7 @@
         </p:nvSpPr>
         <p:spPr>
           <a:xfrm>
-            <a:off x="4526280" y="5760720"/>
+            <a:off x="6080760" y="5879592"/>
             <a:ext cx="3108960" cy="292608"/>
           </a:xfrm>
           <a:prstGeom prst="rect">
@@ -7934,8 +7538,8 @@
         </p:nvSpPr>
         <p:spPr>
           <a:xfrm>
-            <a:off x="868680" y="1975104"/>
-            <a:ext cx="3136392" cy="292608"/>
+            <a:off x="868680" y="1920240"/>
+            <a:ext cx="3136392" cy="1234440"/>
           </a:xfrm>
           <a:prstGeom prst="rect">
             <a:avLst/>
@@ -7963,28 +7567,6 @@
             </a:r>
             <a:endParaRPr lang="en-US" sz="1300" dirty="0"/>
           </a:p>
-        </p:txBody>
-      </p:sp>
-      <p:sp>
-        <p:nvSpPr>
-          <p:cNvPr id="7" name="Text 5"/>
-          <p:cNvSpPr/>
-          <p:nvPr/>
-        </p:nvSpPr>
-        <p:spPr>
-          <a:xfrm>
-            <a:off x="868680" y="2331720"/>
-            <a:ext cx="3136392" cy="795528"/>
-          </a:xfrm>
-          <a:prstGeom prst="rect">
-            <a:avLst/>
-          </a:prstGeom>
-          <a:noFill/>
-          <a:ln/>
-        </p:spPr>
-        <p:txBody>
-          <a:bodyPr wrap="square" lIns="0" tIns="0" rIns="0" bIns="0" rtlCol="0" anchor="ctr"/>
-          <a:lstStyle/>
           <a:p>
             <a:pPr indent="0" marL="0">
               <a:buNone/>
@@ -8000,13 +7582,13 @@
               </a:rPr>
               <a:t>El recorrido existía, pero no estaba formalizado como un solo proceso.</a:t>
             </a:r>
-            <a:endParaRPr lang="en-US" sz="1100" dirty="0"/>
-          </a:p>
-        </p:txBody>
-      </p:sp>
-      <p:sp>
-        <p:nvSpPr>
-          <p:cNvPr id="8" name="Shape 6"/>
+            <a:endParaRPr lang="en-US" sz="1300" dirty="0"/>
+          </a:p>
+        </p:txBody>
+      </p:sp>
+      <p:sp>
+        <p:nvSpPr>
+          <p:cNvPr id="7" name="Shape 5"/>
           <p:cNvSpPr/>
           <p:nvPr/>
         </p:nvSpPr>
@@ -8031,7 +7613,7 @@
       </p:sp>
       <p:sp>
         <p:nvSpPr>
-          <p:cNvPr id="9" name="Shape 7"/>
+          <p:cNvPr id="8" name="Shape 6"/>
           <p:cNvSpPr/>
           <p:nvPr/>
         </p:nvSpPr>
@@ -8056,14 +7638,14 @@
       </p:sp>
       <p:sp>
         <p:nvSpPr>
-          <p:cNvPr id="10" name="Text 8"/>
-          <p:cNvSpPr/>
-          <p:nvPr/>
-        </p:nvSpPr>
-        <p:spPr>
-          <a:xfrm>
-            <a:off x="4599432" y="1975104"/>
-            <a:ext cx="3136392" cy="292608"/>
+          <p:cNvPr id="9" name="Text 7"/>
+          <p:cNvSpPr/>
+          <p:nvPr/>
+        </p:nvSpPr>
+        <p:spPr>
+          <a:xfrm>
+            <a:off x="4599432" y="1920240"/>
+            <a:ext cx="3136392" cy="1234440"/>
           </a:xfrm>
           <a:prstGeom prst="rect">
             <a:avLst/>
@@ -8091,28 +7673,6 @@
             </a:r>
             <a:endParaRPr lang="en-US" sz="1300" dirty="0"/>
           </a:p>
-        </p:txBody>
-      </p:sp>
-      <p:sp>
-        <p:nvSpPr>
-          <p:cNvPr id="11" name="Text 9"/>
-          <p:cNvSpPr/>
-          <p:nvPr/>
-        </p:nvSpPr>
-        <p:spPr>
-          <a:xfrm>
-            <a:off x="4599432" y="2331720"/>
-            <a:ext cx="3136392" cy="795528"/>
-          </a:xfrm>
-          <a:prstGeom prst="rect">
-            <a:avLst/>
-          </a:prstGeom>
-          <a:noFill/>
-          <a:ln/>
-        </p:spPr>
-        <p:txBody>
-          <a:bodyPr wrap="square" lIns="0" tIns="0" rIns="0" bIns="0" rtlCol="0" anchor="ctr"/>
-          <a:lstStyle/>
           <a:p>
             <a:pPr indent="0" marL="0">
               <a:buNone/>
@@ -8128,13 +7688,13 @@
               </a:rPr>
               <a:t>Formatos, estatus, tiempos y comunicación afectaban la trazabilidad.</a:t>
             </a:r>
-            <a:endParaRPr lang="en-US" sz="1100" dirty="0"/>
-          </a:p>
-        </p:txBody>
-      </p:sp>
-      <p:sp>
-        <p:nvSpPr>
-          <p:cNvPr id="12" name="Shape 10"/>
+            <a:endParaRPr lang="en-US" sz="1300" dirty="0"/>
+          </a:p>
+        </p:txBody>
+      </p:sp>
+      <p:sp>
+        <p:nvSpPr>
+          <p:cNvPr id="10" name="Shape 8"/>
           <p:cNvSpPr/>
           <p:nvPr/>
         </p:nvSpPr>
@@ -8159,7 +7719,7 @@
       </p:sp>
       <p:sp>
         <p:nvSpPr>
-          <p:cNvPr id="13" name="Shape 11"/>
+          <p:cNvPr id="11" name="Shape 9"/>
           <p:cNvSpPr/>
           <p:nvPr/>
         </p:nvSpPr>
@@ -8184,14 +7744,14 @@
       </p:sp>
       <p:sp>
         <p:nvSpPr>
-          <p:cNvPr id="14" name="Text 12"/>
-          <p:cNvSpPr/>
-          <p:nvPr/>
-        </p:nvSpPr>
-        <p:spPr>
-          <a:xfrm>
-            <a:off x="8330184" y="1975104"/>
-            <a:ext cx="3136392" cy="292608"/>
+          <p:cNvPr id="12" name="Text 10"/>
+          <p:cNvSpPr/>
+          <p:nvPr/>
+        </p:nvSpPr>
+        <p:spPr>
+          <a:xfrm>
+            <a:off x="8330184" y="1920240"/>
+            <a:ext cx="3136392" cy="1234440"/>
           </a:xfrm>
           <a:prstGeom prst="rect">
             <a:avLst/>
@@ -8219,28 +7779,6 @@
             </a:r>
             <a:endParaRPr lang="en-US" sz="1300" dirty="0"/>
           </a:p>
-        </p:txBody>
-      </p:sp>
-      <p:sp>
-        <p:nvSpPr>
-          <p:cNvPr id="15" name="Text 13"/>
-          <p:cNvSpPr/>
-          <p:nvPr/>
-        </p:nvSpPr>
-        <p:spPr>
-          <a:xfrm>
-            <a:off x="8330184" y="2331720"/>
-            <a:ext cx="3136392" cy="795528"/>
-          </a:xfrm>
-          <a:prstGeom prst="rect">
-            <a:avLst/>
-          </a:prstGeom>
-          <a:noFill/>
-          <a:ln/>
-        </p:spPr>
-        <p:txBody>
-          <a:bodyPr wrap="square" lIns="0" tIns="0" rIns="0" bIns="0" rtlCol="0" anchor="ctr"/>
-          <a:lstStyle/>
           <a:p>
             <a:pPr indent="0" marL="0">
               <a:buNone/>
@@ -8256,13 +7794,13 @@
               </a:rPr>
               <a:t>Flujo, responsables, formatos e indicadores permiten fortalecer el control.</a:t>
             </a:r>
-            <a:endParaRPr lang="en-US" sz="1100" dirty="0"/>
-          </a:p>
-        </p:txBody>
-      </p:sp>
-      <p:sp>
-        <p:nvSpPr>
-          <p:cNvPr id="16" name="Shape 14"/>
+            <a:endParaRPr lang="en-US" sz="1300" dirty="0"/>
+          </a:p>
+        </p:txBody>
+      </p:sp>
+      <p:sp>
+        <p:nvSpPr>
+          <p:cNvPr id="13" name="Shape 11"/>
           <p:cNvSpPr/>
           <p:nvPr/>
         </p:nvSpPr>
@@ -8287,7 +7825,7 @@
       </p:sp>
       <p:sp>
         <p:nvSpPr>
-          <p:cNvPr id="17" name="Shape 15"/>
+          <p:cNvPr id="14" name="Shape 12"/>
           <p:cNvSpPr/>
           <p:nvPr/>
         </p:nvSpPr>
@@ -8312,14 +7850,14 @@
       </p:sp>
       <p:sp>
         <p:nvSpPr>
-          <p:cNvPr id="18" name="Text 16"/>
-          <p:cNvSpPr/>
-          <p:nvPr/>
-        </p:nvSpPr>
-        <p:spPr>
-          <a:xfrm>
-            <a:off x="868680" y="3803904"/>
-            <a:ext cx="4983480" cy="292608"/>
+          <p:cNvPr id="15" name="Text 13"/>
+          <p:cNvSpPr/>
+          <p:nvPr/>
+        </p:nvSpPr>
+        <p:spPr>
+          <a:xfrm>
+            <a:off x="868680" y="3749040"/>
+            <a:ext cx="4983480" cy="1371600"/>
           </a:xfrm>
           <a:prstGeom prst="rect">
             <a:avLst/>
@@ -8347,28 +7885,6 @@
             </a:r>
             <a:endParaRPr lang="en-US" sz="1600" dirty="0"/>
           </a:p>
-        </p:txBody>
-      </p:sp>
-      <p:sp>
-        <p:nvSpPr>
-          <p:cNvPr id="19" name="Text 17"/>
-          <p:cNvSpPr/>
-          <p:nvPr/>
-        </p:nvSpPr>
-        <p:spPr>
-          <a:xfrm>
-            <a:off x="868680" y="4160520"/>
-            <a:ext cx="4983480" cy="932688"/>
-          </a:xfrm>
-          <a:prstGeom prst="rect">
-            <a:avLst/>
-          </a:prstGeom>
-          <a:noFill/>
-          <a:ln/>
-        </p:spPr>
-        <p:txBody>
-          <a:bodyPr wrap="square" lIns="0" tIns="0" rIns="0" bIns="0" rtlCol="0" anchor="ctr"/>
-          <a:lstStyle/>
           <a:p>
             <a:pPr indent="0" marL="0">
               <a:buNone/>
@@ -8384,13 +7900,13 @@
               </a:rPr>
               <a:t>Probar flujo → uniformar formatos → medir resultados → evaluar digitalización.</a:t>
             </a:r>
-            <a:endParaRPr lang="en-US" sz="1200" dirty="0"/>
-          </a:p>
-        </p:txBody>
-      </p:sp>
-      <p:sp>
-        <p:nvSpPr>
-          <p:cNvPr id="20" name="Shape 18"/>
+            <a:endParaRPr lang="en-US" sz="1600" dirty="0"/>
+          </a:p>
+        </p:txBody>
+      </p:sp>
+      <p:sp>
+        <p:nvSpPr>
+          <p:cNvPr id="16" name="Shape 14"/>
           <p:cNvSpPr/>
           <p:nvPr/>
         </p:nvSpPr>
@@ -8415,7 +7931,7 @@
       </p:sp>
       <p:sp>
         <p:nvSpPr>
-          <p:cNvPr id="21" name="Shape 19"/>
+          <p:cNvPr id="17" name="Shape 15"/>
           <p:cNvSpPr/>
           <p:nvPr/>
         </p:nvSpPr>
@@ -8440,14 +7956,14 @@
       </p:sp>
       <p:sp>
         <p:nvSpPr>
-          <p:cNvPr id="22" name="Text 20"/>
-          <p:cNvSpPr/>
-          <p:nvPr/>
-        </p:nvSpPr>
-        <p:spPr>
-          <a:xfrm>
-            <a:off x="6400800" y="3803904"/>
-            <a:ext cx="2148840" cy="292608"/>
+          <p:cNvPr id="18" name="Text 16"/>
+          <p:cNvSpPr/>
+          <p:nvPr/>
+        </p:nvSpPr>
+        <p:spPr>
+          <a:xfrm>
+            <a:off x="6400800" y="3749040"/>
+            <a:ext cx="2148840" cy="1371600"/>
           </a:xfrm>
           <a:prstGeom prst="rect">
             <a:avLst/>
@@ -8475,28 +7991,6 @@
             </a:r>
             <a:endParaRPr lang="en-US" sz="1400" dirty="0"/>
           </a:p>
-        </p:txBody>
-      </p:sp>
-      <p:sp>
-        <p:nvSpPr>
-          <p:cNvPr id="23" name="Text 21"/>
-          <p:cNvSpPr/>
-          <p:nvPr/>
-        </p:nvSpPr>
-        <p:spPr>
-          <a:xfrm>
-            <a:off x="6400800" y="4160520"/>
-            <a:ext cx="2148840" cy="932688"/>
-          </a:xfrm>
-          <a:prstGeom prst="rect">
-            <a:avLst/>
-          </a:prstGeom>
-          <a:noFill/>
-          <a:ln/>
-        </p:spPr>
-        <p:txBody>
-          <a:bodyPr wrap="square" lIns="0" tIns="0" rIns="0" bIns="0" rtlCol="0" anchor="ctr"/>
-          <a:lstStyle/>
           <a:p>
             <a:pPr indent="0" marL="0">
               <a:buNone/>
@@ -8512,13 +8006,13 @@
               </a:rPr>
               <a:t>Fortalecer el acompañamiento académico.</a:t>
             </a:r>
-            <a:endParaRPr lang="en-US" sz="1000" dirty="0"/>
-          </a:p>
-        </p:txBody>
-      </p:sp>
-      <p:sp>
-        <p:nvSpPr>
-          <p:cNvPr id="24" name="Shape 22"/>
+            <a:endParaRPr lang="en-US" sz="1400" dirty="0"/>
+          </a:p>
+        </p:txBody>
+      </p:sp>
+      <p:sp>
+        <p:nvSpPr>
+          <p:cNvPr id="19" name="Shape 17"/>
           <p:cNvSpPr/>
           <p:nvPr/>
         </p:nvSpPr>
@@ -8543,7 +8037,7 @@
       </p:sp>
       <p:sp>
         <p:nvSpPr>
-          <p:cNvPr id="25" name="Shape 23"/>
+          <p:cNvPr id="20" name="Shape 18"/>
           <p:cNvSpPr/>
           <p:nvPr/>
         </p:nvSpPr>
@@ -8568,14 +8062,14 @@
       </p:sp>
       <p:sp>
         <p:nvSpPr>
-          <p:cNvPr id="26" name="Text 24"/>
-          <p:cNvSpPr/>
-          <p:nvPr/>
-        </p:nvSpPr>
-        <p:spPr>
-          <a:xfrm>
-            <a:off x="9098280" y="3803904"/>
-            <a:ext cx="2148840" cy="292608"/>
+          <p:cNvPr id="21" name="Text 19"/>
+          <p:cNvSpPr/>
+          <p:nvPr/>
+        </p:nvSpPr>
+        <p:spPr>
+          <a:xfrm>
+            <a:off x="9098280" y="3749040"/>
+            <a:ext cx="2148840" cy="1371600"/>
           </a:xfrm>
           <a:prstGeom prst="rect">
             <a:avLst/>
@@ -8603,28 +8097,6 @@
             </a:r>
             <a:endParaRPr lang="en-US" sz="1300" dirty="0"/>
           </a:p>
-        </p:txBody>
-      </p:sp>
-      <p:sp>
-        <p:nvSpPr>
-          <p:cNvPr id="27" name="Text 25"/>
-          <p:cNvSpPr/>
-          <p:nvPr/>
-        </p:nvSpPr>
-        <p:spPr>
-          <a:xfrm>
-            <a:off x="9098280" y="4160520"/>
-            <a:ext cx="2148840" cy="932688"/>
-          </a:xfrm>
-          <a:prstGeom prst="rect">
-            <a:avLst/>
-          </a:prstGeom>
-          <a:noFill/>
-          <a:ln/>
-        </p:spPr>
-        <p:txBody>
-          <a:bodyPr wrap="square" lIns="0" tIns="0" rIns="0" bIns="0" rtlCol="0" anchor="ctr"/>
-          <a:lstStyle/>
           <a:p>
             <a:pPr indent="0" marL="0">
               <a:buNone/>
@@ -8640,13 +8112,13 @@
               </a:rPr>
               <a:t>Registrar actividades y conservar evidencias.</a:t>
             </a:r>
-            <a:endParaRPr lang="en-US" sz="1000" dirty="0"/>
-          </a:p>
-        </p:txBody>
-      </p:sp>
-      <p:sp>
-        <p:nvSpPr>
-          <p:cNvPr id="28" name="Text 26"/>
+            <a:endParaRPr lang="en-US" sz="1300" dirty="0"/>
+          </a:p>
+        </p:txBody>
+      </p:sp>
+      <p:sp>
+        <p:nvSpPr>
+          <p:cNvPr id="22" name="Text 20"/>
           <p:cNvSpPr/>
           <p:nvPr/>
         </p:nvSpPr>

</xml_diff>